<commit_message>
Use clipart-style pictures in Lesson 10-1 vocabulary PPT
Reuse the teacher-provided 10-1 PPT pictures where words overlap and use
Fluent Emoji illustrations for the rest; show the Korean meaning next to
each word and add the Look & Listen slide (pp. 124-125).

Co-Authored-By: Claude Opus 5.5 <noreply@anthropic.com>
Claude-Session: https://claude.ai/code/session_01QJZ7rRRbNkEGT2jhq9EkC8
</commit_message>
<xml_diff>
--- a/ppt/Lesson10-1_New_Words.pptx
+++ b/ppt/Lesson10-1_New_Words.pptx
@@ -34,6 +34,7 @@
     <p:sldId id="313" r:id="rId65"/>
     <p:sldId id="314" r:id="rId66"/>
     <p:sldId id="315" r:id="rId67"/>
+    <p:sldId id="295" r:id="rId42"/>
   </p:sldIdLst>
   <p:sldSz cx="12192000" cy="6858000"/>
   <p:notesSz cx="6858000" cy="9144000"/>
@@ -651,7 +652,7 @@
           <a:p>
             <a:r>
               <a:rPr lang="ko-KR"/>
-              <a:t>이미지: OpenMoji(CC BY-SA 4.0, https://openmoji.org) 그림을 조합.</a:t>
+              <a:t>이미지: 선생님이 제공한 10-1 New Words PPT의 교과서 그림.</a:t>
             </a:r>
           </a:p>
         </p:txBody>
@@ -722,7 +723,7 @@
           <a:p>
             <a:r>
               <a:rPr lang="ko-KR"/>
-              <a:t>이미지: OpenMoji(CC BY-SA 4.0, https://openmoji.org) 기반 그림, 가격표·원화 그림은 직접 제작.</a:t>
+              <a:t>이미지: 선생님이 제공한 10-1 New Words PPT 그림 또는 Microsoft Fluent Emoji(MIT License).</a:t>
             </a:r>
           </a:p>
         </p:txBody>
@@ -793,7 +794,7 @@
           <a:p>
             <a:r>
               <a:rPr lang="ko-KR"/>
-              <a:t>이미지: OpenMoji(CC BY-SA 4.0, https://openmoji.org) 기반 그림, 가격표·원화 그림은 직접 제작.</a:t>
+              <a:t>이미지: 선생님이 제공한 10-1 New Words PPT 그림 또는 Microsoft Fluent Emoji(MIT License).</a:t>
             </a:r>
           </a:p>
         </p:txBody>
@@ -864,7 +865,7 @@
           <a:p>
             <a:r>
               <a:rPr lang="ko-KR"/>
-              <a:t>이미지: OpenMoji(CC BY-SA 4.0, https://openmoji.org) 기반 그림, 가격표·원화 그림은 직접 제작.</a:t>
+              <a:t>이미지: 선생님이 제공한 10-1 New Words PPT 그림 또는 Microsoft Fluent Emoji(MIT License).</a:t>
             </a:r>
           </a:p>
         </p:txBody>
@@ -935,7 +936,7 @@
           <a:p>
             <a:r>
               <a:rPr lang="ko-KR"/>
-              <a:t>이미지: OpenMoji(CC BY-SA 4.0, https://openmoji.org) 기반 그림, 가격표·원화 그림은 직접 제작.</a:t>
+              <a:t>이미지: 선생님이 제공한 10-1 New Words PPT 그림 또는 Microsoft Fluent Emoji(MIT License).</a:t>
             </a:r>
           </a:p>
         </p:txBody>
@@ -1006,7 +1007,7 @@
           <a:p>
             <a:r>
               <a:rPr lang="ko-KR"/>
-              <a:t>이미지: OpenMoji(CC BY-SA 4.0, https://openmoji.org) 기반 그림, 가격표·원화 그림은 직접 제작.</a:t>
+              <a:t>이미지: 선생님이 제공한 10-1 New Words PPT 그림 또는 Microsoft Fluent Emoji(MIT License).</a:t>
             </a:r>
           </a:p>
         </p:txBody>
@@ -1077,7 +1078,7 @@
           <a:p>
             <a:r>
               <a:rPr lang="ko-KR"/>
-              <a:t>이미지: OpenMoji(CC BY-SA 4.0, https://openmoji.org) 기반 그림, 가격표·원화 그림은 직접 제작.</a:t>
+              <a:t>이미지: 선생님이 제공한 10-1 New Words PPT 그림 또는 Microsoft Fluent Emoji(MIT License).</a:t>
             </a:r>
           </a:p>
         </p:txBody>
@@ -1148,7 +1149,7 @@
           <a:p>
             <a:r>
               <a:rPr lang="ko-KR"/>
-              <a:t>이미지: OpenMoji(CC BY-SA 4.0, https://openmoji.org) 기반 그림, 가격표·원화 그림은 직접 제작.</a:t>
+              <a:t>이미지: 선생님이 제공한 10-1 New Words PPT 그림 또는 Microsoft Fluent Emoji(MIT License).</a:t>
             </a:r>
           </a:p>
         </p:txBody>
@@ -1219,7 +1220,7 @@
           <a:p>
             <a:r>
               <a:rPr lang="ko-KR"/>
-              <a:t>이미지: OpenMoji(CC BY-SA 4.0, https://openmoji.org) 기반 그림, 가격표·원화 그림은 직접 제작.</a:t>
+              <a:t>이미지: 선생님이 제공한 10-1 New Words PPT 그림 또는 Microsoft Fluent Emoji(MIT License).</a:t>
             </a:r>
           </a:p>
         </p:txBody>
@@ -1290,7 +1291,7 @@
           <a:p>
             <a:r>
               <a:rPr lang="ko-KR"/>
-              <a:t>이미지: OpenMoji(CC BY-SA 4.0, https://openmoji.org) 기반 그림, 가격표·원화 그림은 직접 제작.</a:t>
+              <a:t>이미지: 선생님이 제공한 10-1 New Words PPT 그림 또는 Microsoft Fluent Emoji(MIT License).</a:t>
             </a:r>
           </a:p>
         </p:txBody>
@@ -1361,7 +1362,7 @@
           <a:p>
             <a:r>
               <a:rPr lang="ko-KR"/>
-              <a:t>이미지: OpenMoji(CC BY-SA 4.0, https://openmoji.org) 기반 그림, 가격표·원화 그림은 직접 제작.</a:t>
+              <a:t>이미지: 선생님이 제공한 10-1 New Words PPT 그림 또는 Microsoft Fluent Emoji(MIT License).</a:t>
             </a:r>
           </a:p>
         </p:txBody>
@@ -1485,7 +1486,7 @@
           <a:p>
             <a:r>
               <a:rPr lang="ko-KR"/>
-              <a:t>이미지: OpenMoji(CC BY-SA 4.0, https://openmoji.org) 기반 그림, 가격표·원화 그림은 직접 제작.</a:t>
+              <a:t>이미지: 선생님이 제공한 10-1 New Words PPT 그림 또는 Microsoft Fluent Emoji(MIT License).</a:t>
             </a:r>
           </a:p>
         </p:txBody>
@@ -1556,7 +1557,7 @@
           <a:p>
             <a:r>
               <a:rPr lang="ko-KR"/>
-              <a:t>이미지: OpenMoji(CC BY-SA 4.0, https://openmoji.org) 기반 그림, 가격표·원화 그림은 직접 제작.</a:t>
+              <a:t>이미지: 선생님이 제공한 10-1 New Words PPT 그림 또는 Microsoft Fluent Emoji(MIT License).</a:t>
             </a:r>
           </a:p>
         </p:txBody>
@@ -1627,7 +1628,7 @@
           <a:p>
             <a:r>
               <a:rPr lang="ko-KR"/>
-              <a:t>이미지: OpenMoji(CC BY-SA 4.0, https://openmoji.org) 기반 그림, 가격표·원화 그림은 직접 제작.</a:t>
+              <a:t>이미지: 선생님이 제공한 10-1 New Words PPT 그림 또는 Microsoft Fluent Emoji(MIT License).</a:t>
             </a:r>
           </a:p>
         </p:txBody>
@@ -1698,7 +1699,7 @@
           <a:p>
             <a:r>
               <a:rPr lang="ko-KR"/>
-              <a:t>이미지: OpenMoji(CC BY-SA 4.0, https://openmoji.org) 기반 그림, 가격표·원화 그림은 직접 제작.</a:t>
+              <a:t>이미지: 선생님이 제공한 10-1 New Words PPT 그림 또는 Microsoft Fluent Emoji(MIT License).</a:t>
             </a:r>
           </a:p>
         </p:txBody>
@@ -1822,7 +1823,7 @@
           <a:p>
             <a:r>
               <a:rPr lang="ko-KR"/>
-              <a:t>이미지: OpenMoji(CC BY-SA 4.0, https://openmoji.org) 기반 그림, 가격표·원화 그림은 직접 제작.</a:t>
+              <a:t>이미지: 선생님이 제공한 10-1 New Words PPT 그림 또는 Microsoft Fluent Emoji(MIT License).</a:t>
             </a:r>
           </a:p>
         </p:txBody>
@@ -1946,7 +1947,60 @@
           <a:p>
             <a:r>
               <a:rPr lang="ko-KR"/>
-              <a:t>이미지: OpenMoji(CC BY-SA 4.0, https://openmoji.org) 기반 그림, 가격표·원화 그림은 직접 제작.</a:t>
+              <a:t>이미지: 선생님이 제공한 10-1 New Words PPT 그림 또는 Microsoft Fluent Emoji(MIT License).</a:t>
+            </a:r>
+          </a:p>
+        </p:txBody>
+      </p:sp>
+    </p:spTree>
+  </p:cSld>
+  <p:clrMapOvr>
+    <a:masterClrMapping/>
+  </p:clrMapOvr>
+</p:notes>
+</file>
+
+<file path=ppt/notesSlides/notesSlide40.xml><?xml version="1.0" encoding="utf-8"?>
+<p:notes xmlns:a="http://schemas.openxmlformats.org/drawingml/2006/main" xmlns:r="http://schemas.openxmlformats.org/officeDocument/2006/relationships" xmlns:p="http://schemas.openxmlformats.org/presentationml/2006/main">
+  <p:cSld>
+    <p:spTree>
+      <p:nvGrpSpPr>
+        <p:cNvPr id="1" name=""/>
+        <p:cNvGrpSpPr/>
+        <p:nvPr/>
+      </p:nvGrpSpPr>
+      <p:grpSpPr>
+        <a:xfrm>
+          <a:off x="0" y="0"/>
+          <a:ext cx="0" cy="0"/>
+          <a:chOff x="0" y="0"/>
+          <a:chExt cx="0" cy="0"/>
+        </a:xfrm>
+      </p:grpSpPr>
+      <p:sp>
+        <p:nvSpPr>
+          <p:cNvPr id="2" name="Notes"/>
+          <p:cNvSpPr>
+            <a:spLocks noGrp="1"/>
+          </p:cNvSpPr>
+          <p:nvPr>
+            <p:ph type="body" idx="1"/>
+          </p:nvPr>
+        </p:nvSpPr>
+        <p:spPr/>
+        <p:txBody>
+          <a:bodyPr/>
+          <a:lstStyle/>
+          <a:p>
+            <a:r>
+              <a:rPr lang="ko-KR"/>
+              <a:t>자료: 5학년 YBM 최 10단원 활동지 (Lesson 10. How Much Are These Socks?)</a:t>
+            </a:r>
+          </a:p>
+          <a:p>
+            <a:r>
+              <a:rPr lang="ko-KR"/>
+              <a:t>보너스 단어 11–18, 심화 단어 19–21 포함</a:t>
             </a:r>
           </a:p>
         </p:txBody>
@@ -2017,7 +2071,7 @@
           <a:p>
             <a:r>
               <a:rPr lang="ko-KR"/>
-              <a:t>이미지: OpenMoji(CC BY-SA 4.0, https://openmoji.org) 기반 그림, 가격표·원화 그림은 직접 제작.</a:t>
+              <a:t>이미지: 선생님이 제공한 10-1 New Words PPT 그림 또는 Microsoft Fluent Emoji(MIT License).</a:t>
             </a:r>
           </a:p>
         </p:txBody>
@@ -2088,7 +2142,7 @@
           <a:p>
             <a:r>
               <a:rPr lang="ko-KR"/>
-              <a:t>이미지: OpenMoji(CC BY-SA 4.0, https://openmoji.org) 기반 그림, 가격표·원화 그림은 직접 제작.</a:t>
+              <a:t>이미지: 선생님이 제공한 10-1 New Words PPT 그림 또는 Microsoft Fluent Emoji(MIT License).</a:t>
             </a:r>
           </a:p>
         </p:txBody>
@@ -2159,7 +2213,7 @@
           <a:p>
             <a:r>
               <a:rPr lang="ko-KR"/>
-              <a:t>이미지: OpenMoji(CC BY-SA 4.0, https://openmoji.org) 기반 그림, 가격표·원화 그림은 직접 제작.</a:t>
+              <a:t>이미지: 선생님이 제공한 10-1 New Words PPT 그림 또는 Microsoft Fluent Emoji(MIT License).</a:t>
             </a:r>
           </a:p>
         </p:txBody>
@@ -2230,7 +2284,7 @@
           <a:p>
             <a:r>
               <a:rPr lang="ko-KR"/>
-              <a:t>이미지: OpenMoji(CC BY-SA 4.0, https://openmoji.org) 기반 그림, 가격표·원화 그림은 직접 제작.</a:t>
+              <a:t>이미지: 선생님이 제공한 10-1 New Words PPT 그림 또는 Microsoft Fluent Emoji(MIT License).</a:t>
             </a:r>
           </a:p>
         </p:txBody>
@@ -2301,7 +2355,7 @@
           <a:p>
             <a:r>
               <a:rPr lang="ko-KR"/>
-              <a:t>이미지: OpenMoji(CC BY-SA 4.0, https://openmoji.org) 기반 그림, 가격표·원화 그림은 직접 제작.</a:t>
+              <a:t>이미지: 선생님이 제공한 10-1 New Words PPT 그림 또는 Microsoft Fluent Emoji(MIT License).</a:t>
             </a:r>
           </a:p>
         </p:txBody>
@@ -10133,6 +10187,18 @@
               </a:rPr>
               <a:t>socks</a:t>
             </a:r>
+            <a:r>
+              <a:rPr lang="ko-KR" altLang="en-US" sz="3200" dirty="0">
+                <a:solidFill>
+                  <a:schemeClr val="tx1">
+                    <a:lumMod val="85000"/>
+                    <a:lumOff val="15000"/>
+                  </a:schemeClr>
+                </a:solidFill>
+                <a:ea typeface="맑은 고딕"/>
+              </a:rPr>
+              <a:t xml:space="preserve"> ( 양말 )</a:t>
+            </a:r>
             <a:endParaRPr lang="ko-KR" sz="4400"/>
           </a:p>
         </p:txBody>
@@ -10349,6 +10415,147 @@
 </p:sld>
 </file>
 
+<file path=ppt/slides/slide40.xml><?xml version="1.0" encoding="utf-8"?>
+<p:sld xmlns:a="http://schemas.openxmlformats.org/drawingml/2006/main" xmlns:r="http://schemas.openxmlformats.org/officeDocument/2006/relationships" xmlns:p="http://schemas.openxmlformats.org/presentationml/2006/main">
+  <p:cSld>
+    <p:spTree>
+      <p:nvGrpSpPr>
+        <p:cNvPr id="1" name=""/>
+        <p:cNvGrpSpPr/>
+        <p:nvPr/>
+      </p:nvGrpSpPr>
+      <p:grpSpPr>
+        <a:xfrm>
+          <a:off x="0" y="0"/>
+          <a:ext cx="0" cy="0"/>
+          <a:chOff x="0" y="0"/>
+          <a:chExt cx="0" cy="0"/>
+        </a:xfrm>
+      </p:grpSpPr>
+      <p:sp>
+        <p:nvSpPr>
+          <p:cNvPr id="2" name="Rectangle 1"/>
+          <p:cNvSpPr/>
+          <p:nvPr/>
+        </p:nvSpPr>
+        <p:spPr>
+          <a:xfrm>
+            <a:off x="1631504" y="2492896"/>
+            <a:ext cx="9144000" cy="1323439"/>
+          </a:xfrm>
+          <a:prstGeom prst="rect">
+            <a:avLst/>
+          </a:prstGeom>
+          <a:solidFill>
+            <a:srgbClr val="FF5050"/>
+          </a:solidFill>
+        </p:spPr>
+        <p:txBody>
+          <a:bodyPr wrap="square">
+            <a:spAutoFit/>
+            <a:scene3d>
+              <a:camera prst="orthographicFront"/>
+              <a:lightRig rig="flat" dir="tl">
+                <a:rot lat="0" lon="0" rev="6600000"/>
+              </a:lightRig>
+            </a:scene3d>
+            <a:sp3d extrusionH="25400" contourW="8890">
+              <a:bevelT w="38100" h="31750"/>
+              <a:contourClr>
+                <a:schemeClr val="accent2">
+                  <a:shade val="75000"/>
+                </a:schemeClr>
+              </a:contourClr>
+            </a:sp3d>
+          </a:bodyPr>
+          <a:lstStyle/>
+          <a:p>
+            <a:pPr algn="ctr" fontAlgn="auto">
+              <a:spcBef>
+                <a:spcPts val="0"/>
+              </a:spcBef>
+              <a:spcAft>
+                <a:spcPts val="0"/>
+              </a:spcAft>
+              <a:defRPr/>
+            </a:pPr>
+            <a:r>
+              <a:rPr kumimoji="0" lang="en-US" altLang="ko-KR" sz="8000" b="1" dirty="0">
+                <a:ln w="11430">
+                  <a:solidFill>
+                    <a:schemeClr val="bg1"/>
+                  </a:solidFill>
+                </a:ln>
+                <a:solidFill>
+                  <a:schemeClr val="bg1"/>
+                </a:solidFill>
+                <a:latin typeface="a아띠" panose="02020600000000000000" pitchFamily="18" charset="-127"/>
+                <a:ea typeface="맑은 고딕" panose="02020600000000000000" pitchFamily="18" charset="-127"/>
+              </a:rPr>
+              <a:t>Look &amp; Listen</a:t>
+            </a:r>
+            <a:endParaRPr lang="ko-KR" sz="8000"/>
+          </a:p>
+        </p:txBody>
+      </p:sp>
+      <p:sp>
+        <p:nvSpPr>
+          <p:cNvPr id="4" name="TextBox 3">
+            <a:extLst>
+              <a:ext uri="{FF2B5EF4-FFF2-40B4-BE49-F238E27FC236}">
+                <a16:creationId xmlns:a16="http://schemas.microsoft.com/office/drawing/2014/main" id="{749F342D-7DFC-4108-AB2E-30575B28B261}"/>
+              </a:ext>
+            </a:extLst>
+          </p:cNvPr>
+          <p:cNvSpPr txBox="1"/>
+          <p:nvPr/>
+        </p:nvSpPr>
+        <p:spPr>
+          <a:xfrm>
+            <a:off x="5238750" y="4143375"/>
+            <a:ext cx="6191250" cy="762000"/>
+          </a:xfrm>
+          <a:prstGeom prst="rect">
+            <a:avLst/>
+          </a:prstGeom>
+          <a:noFill/>
+        </p:spPr>
+        <p:txBody>
+          <a:bodyPr wrap="square" rtlCol="0">
+            <a:spAutoFit/>
+          </a:bodyPr>
+          <a:lstStyle/>
+          <a:p>
+            <a:r>
+              <a:rPr lang="en-US" altLang="ko-KR" sz="2800" dirty="0">
+                <a:solidFill>
+                  <a:schemeClr val="tx1">
+                    <a:lumMod val="75000"/>
+                    <a:lumOff val="25000"/>
+                  </a:schemeClr>
+                </a:solidFill>
+                <a:latin typeface="a아띠" panose="02020600000000000000" pitchFamily="18" charset="-127"/>
+                <a:ea typeface="맑은 고딕" panose="02020600000000000000" pitchFamily="18" charset="-127"/>
+              </a:rPr>
+              <a:t>Lesson 10 · pp. 124–125</a:t>
+            </a:r>
+            <a:endParaRPr lang="ko-KR" sz="2800"/>
+          </a:p>
+        </p:txBody>
+      </p:sp>
+    </p:spTree>
+    <p:extLst>
+      <p:ext uri="{BB962C8B-B14F-4D97-AF65-F5344CB8AC3E}">
+        <p14:creationId xmlns:p14="http://schemas.microsoft.com/office/powerpoint/2010/main" val="4274623718"/>
+      </p:ext>
+    </p:extLst>
+  </p:cSld>
+  <p:clrMapOvr>
+    <a:masterClrMapping/>
+  </p:clrMapOvr>
+</p:sld>
+</file>
+
 <file path=ppt/slides/slide41.xml><?xml version="1.0" encoding="utf-8"?>
 <p:sld xmlns:a="http://schemas.openxmlformats.org/drawingml/2006/main" xmlns:r="http://schemas.openxmlformats.org/officeDocument/2006/relationships" xmlns:p="http://schemas.openxmlformats.org/presentationml/2006/main">
   <p:cSld>
@@ -10425,6 +10632,18 @@
                 <a:ea typeface="맑은 고딕"/>
               </a:rPr>
               <a:t>gloves</a:t>
+            </a:r>
+            <a:r>
+              <a:rPr lang="ko-KR" altLang="en-US" sz="3200" dirty="0">
+                <a:solidFill>
+                  <a:schemeClr val="tx1">
+                    <a:lumMod val="85000"/>
+                    <a:lumOff val="15000"/>
+                  </a:schemeClr>
+                </a:solidFill>
+                <a:ea typeface="맑은 고딕"/>
+              </a:rPr>
+              <a:t xml:space="preserve"> ( 장갑 )</a:t>
             </a:r>
             <a:endParaRPr lang="ko-KR" sz="4400"/>
           </a:p>
@@ -10630,6 +10849,18 @@
               </a:rPr>
               <a:t>sunglasses</a:t>
             </a:r>
+            <a:r>
+              <a:rPr lang="ko-KR" altLang="en-US" sz="3200" dirty="0">
+                <a:solidFill>
+                  <a:schemeClr val="tx1">
+                    <a:lumMod val="85000"/>
+                    <a:lumOff val="15000"/>
+                  </a:schemeClr>
+                </a:solidFill>
+                <a:ea typeface="맑은 고딕"/>
+              </a:rPr>
+              <a:t xml:space="preserve"> ( 선글라스 )</a:t>
+            </a:r>
             <a:endParaRPr lang="ko-KR" sz="4400"/>
           </a:p>
         </p:txBody>
@@ -10650,8 +10881,8 @@
         </p:blipFill>
         <p:spPr>
           <a:xfrm>
-            <a:off x="3810000" y="1762125"/>
-            <a:ext cx="4572000" cy="4572000"/>
+            <a:off x="2896001" y="2214742"/>
+            <a:ext cx="6399999" cy="3666766"/>
           </a:xfrm>
           <a:prstGeom prst="rect">
             <a:avLst/>
@@ -10833,6 +11064,18 @@
                 <a:ea typeface="맑은 고딕"/>
               </a:rPr>
               <a:t>shoes</a:t>
+            </a:r>
+            <a:r>
+              <a:rPr lang="ko-KR" altLang="en-US" sz="3200" dirty="0">
+                <a:solidFill>
+                  <a:schemeClr val="tx1">
+                    <a:lumMod val="85000"/>
+                    <a:lumOff val="15000"/>
+                  </a:schemeClr>
+                </a:solidFill>
+                <a:ea typeface="맑은 고딕"/>
+              </a:rPr>
+              <a:t xml:space="preserve"> ( 신발 )</a:t>
             </a:r>
             <a:endParaRPr lang="ko-KR" sz="4400"/>
           </a:p>
@@ -11038,6 +11281,18 @@
               </a:rPr>
               <a:t>pants</a:t>
             </a:r>
+            <a:r>
+              <a:rPr lang="ko-KR" altLang="en-US" sz="3200" dirty="0">
+                <a:solidFill>
+                  <a:schemeClr val="tx1">
+                    <a:lumMod val="85000"/>
+                    <a:lumOff val="15000"/>
+                  </a:schemeClr>
+                </a:solidFill>
+                <a:ea typeface="맑은 고딕"/>
+              </a:rPr>
+              <a:t xml:space="preserve"> ( 바지 )</a:t>
+            </a:r>
             <a:endParaRPr lang="ko-KR" sz="4400"/>
           </a:p>
         </p:txBody>
@@ -11058,8 +11313,8 @@
         </p:blipFill>
         <p:spPr>
           <a:xfrm>
-            <a:off x="3810000" y="1762125"/>
-            <a:ext cx="4572000" cy="4572000"/>
+            <a:off x="4249065" y="1762125"/>
+            <a:ext cx="3693870" cy="4572000"/>
           </a:xfrm>
           <a:prstGeom prst="rect">
             <a:avLst/>
@@ -11241,6 +11496,18 @@
                 <a:ea typeface="맑은 고딕"/>
               </a:rPr>
               <a:t>cap</a:t>
+            </a:r>
+            <a:r>
+              <a:rPr lang="ko-KR" altLang="en-US" sz="3200" dirty="0">
+                <a:solidFill>
+                  <a:schemeClr val="tx1">
+                    <a:lumMod val="85000"/>
+                    <a:lumOff val="15000"/>
+                  </a:schemeClr>
+                </a:solidFill>
+                <a:ea typeface="맑은 고딕"/>
+              </a:rPr>
+              <a:t xml:space="preserve"> ( 모자 )</a:t>
             </a:r>
             <a:endParaRPr lang="ko-KR" sz="4400"/>
           </a:p>
@@ -11446,6 +11713,18 @@
               </a:rPr>
               <a:t>T-shirt</a:t>
             </a:r>
+            <a:r>
+              <a:rPr lang="ko-KR" altLang="en-US" sz="3200" dirty="0">
+                <a:solidFill>
+                  <a:schemeClr val="tx1">
+                    <a:lumMod val="85000"/>
+                    <a:lumOff val="15000"/>
+                  </a:schemeClr>
+                </a:solidFill>
+                <a:ea typeface="맑은 고딕"/>
+              </a:rPr>
+              <a:t xml:space="preserve"> ( 티셔츠 )</a:t>
+            </a:r>
             <a:endParaRPr lang="ko-KR" sz="4400"/>
           </a:p>
         </p:txBody>
@@ -11650,6 +11929,18 @@
               </a:rPr>
               <a:t>size</a:t>
             </a:r>
+            <a:r>
+              <a:rPr lang="ko-KR" altLang="en-US" sz="3200" dirty="0">
+                <a:solidFill>
+                  <a:schemeClr val="tx1">
+                    <a:lumMod val="85000"/>
+                    <a:lumOff val="15000"/>
+                  </a:schemeClr>
+                </a:solidFill>
+                <a:ea typeface="맑은 고딕"/>
+              </a:rPr>
+              <a:t xml:space="preserve"> ( 크기, 치수 )</a:t>
+            </a:r>
             <a:endParaRPr lang="ko-KR" sz="4400"/>
           </a:p>
         </p:txBody>
@@ -11854,6 +12145,18 @@
               </a:rPr>
               <a:t>large</a:t>
             </a:r>
+            <a:r>
+              <a:rPr lang="ko-KR" altLang="en-US" sz="3200" dirty="0">
+                <a:solidFill>
+                  <a:schemeClr val="tx1">
+                    <a:lumMod val="85000"/>
+                    <a:lumOff val="15000"/>
+                  </a:schemeClr>
+                </a:solidFill>
+                <a:ea typeface="맑은 고딕"/>
+              </a:rPr>
+              <a:t xml:space="preserve"> ( 큰 )</a:t>
+            </a:r>
             <a:endParaRPr lang="ko-KR" sz="4400"/>
           </a:p>
         </p:txBody>
@@ -12058,6 +12361,18 @@
               </a:rPr>
               <a:t>won</a:t>
             </a:r>
+            <a:r>
+              <a:rPr lang="ko-KR" altLang="en-US" sz="3200" dirty="0">
+                <a:solidFill>
+                  <a:schemeClr val="tx1">
+                    <a:lumMod val="85000"/>
+                    <a:lumOff val="15000"/>
+                  </a:schemeClr>
+                </a:solidFill>
+                <a:ea typeface="맑은 고딕"/>
+              </a:rPr>
+              <a:t xml:space="preserve"> ( 원 )</a:t>
+            </a:r>
             <a:endParaRPr lang="ko-KR" sz="4400"/>
           </a:p>
         </p:txBody>
@@ -12078,8 +12393,8 @@
         </p:blipFill>
         <p:spPr>
           <a:xfrm>
-            <a:off x="3810000" y="1762125"/>
-            <a:ext cx="4572000" cy="4572000"/>
+            <a:off x="3309454" y="1762125"/>
+            <a:ext cx="5573092" cy="4572000"/>
           </a:xfrm>
           <a:prstGeom prst="rect">
             <a:avLst/>
@@ -12262,6 +12577,18 @@
               </a:rPr>
               <a:t>cheap</a:t>
             </a:r>
+            <a:r>
+              <a:rPr lang="ko-KR" altLang="en-US" sz="3200" dirty="0">
+                <a:solidFill>
+                  <a:schemeClr val="tx1">
+                    <a:lumMod val="85000"/>
+                    <a:lumOff val="15000"/>
+                  </a:schemeClr>
+                </a:solidFill>
+                <a:ea typeface="맑은 고딕"/>
+              </a:rPr>
+              <a:t xml:space="preserve"> ( 값이 싼 )</a:t>
+            </a:r>
             <a:endParaRPr lang="ko-KR" sz="4400"/>
           </a:p>
         </p:txBody>
@@ -12282,8 +12609,8 @@
         </p:blipFill>
         <p:spPr>
           <a:xfrm>
-            <a:off x="3810000" y="1762125"/>
-            <a:ext cx="4572000" cy="4572000"/>
+            <a:off x="2896000" y="1807276"/>
+            <a:ext cx="6400000" cy="4481697"/>
           </a:xfrm>
           <a:prstGeom prst="rect">
             <a:avLst/>
@@ -12466,6 +12793,18 @@
               </a:rPr>
               <a:t>expensive</a:t>
             </a:r>
+            <a:r>
+              <a:rPr lang="ko-KR" altLang="en-US" sz="3200" dirty="0">
+                <a:solidFill>
+                  <a:schemeClr val="tx1">
+                    <a:lumMod val="85000"/>
+                    <a:lumOff val="15000"/>
+                  </a:schemeClr>
+                </a:solidFill>
+                <a:ea typeface="맑은 고딕"/>
+              </a:rPr>
+              <a:t xml:space="preserve"> ( 비싼 )</a:t>
+            </a:r>
             <a:endParaRPr lang="ko-KR" sz="4400"/>
           </a:p>
         </p:txBody>
@@ -12486,8 +12825,8 @@
         </p:blipFill>
         <p:spPr>
           <a:xfrm>
-            <a:off x="3810000" y="1762125"/>
-            <a:ext cx="4572000" cy="4572000"/>
+            <a:off x="3137926" y="1762125"/>
+            <a:ext cx="5916149" cy="4572000"/>
           </a:xfrm>
           <a:prstGeom prst="rect">
             <a:avLst/>
@@ -12670,6 +13009,18 @@
               </a:rPr>
               <a:t>price</a:t>
             </a:r>
+            <a:r>
+              <a:rPr lang="ko-KR" altLang="en-US" sz="3200" dirty="0">
+                <a:solidFill>
+                  <a:schemeClr val="tx1">
+                    <a:lumMod val="85000"/>
+                    <a:lumOff val="15000"/>
+                  </a:schemeClr>
+                </a:solidFill>
+                <a:ea typeface="맑은 고딕"/>
+              </a:rPr>
+              <a:t xml:space="preserve"> ( 가격 )</a:t>
+            </a:r>
             <a:endParaRPr lang="ko-KR" sz="4400"/>
           </a:p>
         </p:txBody>
@@ -12690,8 +13041,8 @@
         </p:blipFill>
         <p:spPr>
           <a:xfrm>
-            <a:off x="3810000" y="1762125"/>
-            <a:ext cx="4572000" cy="4572000"/>
+            <a:off x="3314299" y="1762125"/>
+            <a:ext cx="5563402" cy="4572000"/>
           </a:xfrm>
           <a:prstGeom prst="rect">
             <a:avLst/>
@@ -12874,6 +13225,18 @@
               </a:rPr>
               <a:t>buy</a:t>
             </a:r>
+            <a:r>
+              <a:rPr lang="ko-KR" altLang="en-US" sz="3200" dirty="0">
+                <a:solidFill>
+                  <a:schemeClr val="tx1">
+                    <a:lumMod val="85000"/>
+                    <a:lumOff val="15000"/>
+                  </a:schemeClr>
+                </a:solidFill>
+                <a:ea typeface="맑은 고딕"/>
+              </a:rPr>
+              <a:t xml:space="preserve"> ( 사다 )</a:t>
+            </a:r>
             <a:endParaRPr lang="ko-KR" sz="4400"/>
           </a:p>
         </p:txBody>
@@ -12894,8 +13257,8 @@
         </p:blipFill>
         <p:spPr>
           <a:xfrm>
-            <a:off x="3810000" y="1762125"/>
-            <a:ext cx="4572000" cy="4572000"/>
+            <a:off x="3308196" y="1762125"/>
+            <a:ext cx="5575609" cy="4572000"/>
           </a:xfrm>
           <a:prstGeom prst="rect">
             <a:avLst/>
@@ -13077,6 +13440,18 @@
                 <a:ea typeface="맑은 고딕"/>
               </a:rPr>
               <a:t>sell</a:t>
+            </a:r>
+            <a:r>
+              <a:rPr lang="ko-KR" altLang="en-US" sz="3200" dirty="0">
+                <a:solidFill>
+                  <a:schemeClr val="tx1">
+                    <a:lumMod val="85000"/>
+                    <a:lumOff val="15000"/>
+                  </a:schemeClr>
+                </a:solidFill>
+                <a:ea typeface="맑은 고딕"/>
+              </a:rPr>
+              <a:t xml:space="preserve"> ( 팔다 )</a:t>
             </a:r>
             <a:endParaRPr lang="ko-KR" sz="4400"/>
           </a:p>
@@ -13282,6 +13657,18 @@
               </a:rPr>
               <a:t>small</a:t>
             </a:r>
+            <a:r>
+              <a:rPr lang="ko-KR" altLang="en-US" sz="3200" dirty="0">
+                <a:solidFill>
+                  <a:schemeClr val="tx1">
+                    <a:lumMod val="85000"/>
+                    <a:lumOff val="15000"/>
+                  </a:schemeClr>
+                </a:solidFill>
+                <a:ea typeface="맑은 고딕"/>
+              </a:rPr>
+              <a:t xml:space="preserve"> ( 작은 )</a:t>
+            </a:r>
             <a:endParaRPr lang="ko-KR" sz="4400"/>
           </a:p>
         </p:txBody>
@@ -13486,6 +13873,18 @@
               </a:rPr>
               <a:t>color</a:t>
             </a:r>
+            <a:r>
+              <a:rPr lang="ko-KR" altLang="en-US" sz="3200" dirty="0">
+                <a:solidFill>
+                  <a:schemeClr val="tx1">
+                    <a:lumMod val="85000"/>
+                    <a:lumOff val="15000"/>
+                  </a:schemeClr>
+                </a:solidFill>
+                <a:ea typeface="맑은 고딕"/>
+              </a:rPr>
+              <a:t xml:space="preserve"> ( 색깔 )</a:t>
+            </a:r>
             <a:endParaRPr lang="ko-KR" sz="4400"/>
           </a:p>
         </p:txBody>
@@ -13690,6 +14089,18 @@
               </a:rPr>
               <a:t>on sale</a:t>
             </a:r>
+            <a:r>
+              <a:rPr lang="ko-KR" altLang="en-US" sz="3200" dirty="0">
+                <a:solidFill>
+                  <a:schemeClr val="tx1">
+                    <a:lumMod val="85000"/>
+                    <a:lumOff val="15000"/>
+                  </a:schemeClr>
+                </a:solidFill>
+                <a:ea typeface="맑은 고딕"/>
+              </a:rPr>
+              <a:t xml:space="preserve"> ( 할인 중인 )</a:t>
+            </a:r>
             <a:endParaRPr lang="ko-KR" sz="4400"/>
           </a:p>
         </p:txBody>
@@ -13710,8 +14121,8 @@
         </p:blipFill>
         <p:spPr>
           <a:xfrm>
-            <a:off x="3810000" y="1762125"/>
-            <a:ext cx="4572000" cy="4572000"/>
+            <a:off x="3578732" y="1762125"/>
+            <a:ext cx="5034536" cy="4572000"/>
           </a:xfrm>
           <a:prstGeom prst="rect">
             <a:avLst/>
@@ -13893,6 +14304,18 @@
                 <a:ea typeface="맑은 고딕"/>
               </a:rPr>
               <a:t>receipt</a:t>
+            </a:r>
+            <a:r>
+              <a:rPr lang="ko-KR" altLang="en-US" sz="3200" dirty="0">
+                <a:solidFill>
+                  <a:schemeClr val="tx1">
+                    <a:lumMod val="85000"/>
+                    <a:lumOff val="15000"/>
+                  </a:schemeClr>
+                </a:solidFill>
+                <a:ea typeface="맑은 고딕"/>
+              </a:rPr>
+              <a:t xml:space="preserve"> ( 영수증 )</a:t>
             </a:r>
             <a:endParaRPr lang="ko-KR" sz="4400"/>
           </a:p>
@@ -14098,6 +14521,18 @@
               </a:rPr>
               <a:t>change</a:t>
             </a:r>
+            <a:r>
+              <a:rPr lang="ko-KR" altLang="en-US" sz="3200" dirty="0">
+                <a:solidFill>
+                  <a:schemeClr val="tx1">
+                    <a:lumMod val="85000"/>
+                    <a:lumOff val="15000"/>
+                  </a:schemeClr>
+                </a:solidFill>
+                <a:ea typeface="맑은 고딕"/>
+              </a:rPr>
+              <a:t xml:space="preserve"> ( 거스름돈 )</a:t>
+            </a:r>
             <a:endParaRPr lang="ko-KR" sz="4400"/>
           </a:p>
         </p:txBody>
@@ -14118,8 +14553,8 @@
         </p:blipFill>
         <p:spPr>
           <a:xfrm>
-            <a:off x="3810000" y="1762125"/>
-            <a:ext cx="4572000" cy="4572000"/>
+            <a:off x="2896000" y="1913140"/>
+            <a:ext cx="6400000" cy="4269969"/>
           </a:xfrm>
           <a:prstGeom prst="rect">
             <a:avLst/>
@@ -14301,6 +14736,18 @@
                 <a:ea typeface="맑은 고딕"/>
               </a:rPr>
               <a:t>total</a:t>
+            </a:r>
+            <a:r>
+              <a:rPr lang="ko-KR" altLang="en-US" sz="3200" dirty="0">
+                <a:solidFill>
+                  <a:schemeClr val="tx1">
+                    <a:lumMod val="85000"/>
+                    <a:lumOff val="15000"/>
+                  </a:schemeClr>
+                </a:solidFill>
+                <a:ea typeface="맑은 고딕"/>
+              </a:rPr>
+              <a:t xml:space="preserve"> ( 합계 )</a:t>
             </a:r>
             <a:endParaRPr lang="ko-KR" sz="4400"/>
           </a:p>

</xml_diff>

<commit_message>
Use 3D-rendered pictures in Lesson 10-1 vocabulary PPT
Co-Authored-By: Claude Opus 5.5 <noreply@anthropic.com>
Claude-Session: https://claude.ai/code/session_01QJZ7rRRbNkEGT2jhq9EkC8
</commit_message>
<xml_diff>
--- a/ppt/Lesson10-1_New_Words.pptx
+++ b/ppt/Lesson10-1_New_Words.pptx
@@ -11961,8 +11961,8 @@
         </p:blipFill>
         <p:spPr>
           <a:xfrm>
-            <a:off x="3810000" y="1762125"/>
-            <a:ext cx="4572000" cy="4572000"/>
+            <a:off x="2896000" y="2491882"/>
+            <a:ext cx="6400000" cy="3112485"/>
           </a:xfrm>
           <a:prstGeom prst="rect">
             <a:avLst/>
@@ -12177,8 +12177,8 @@
         </p:blipFill>
         <p:spPr>
           <a:xfrm>
-            <a:off x="3810000" y="1762125"/>
-            <a:ext cx="4572000" cy="4572000"/>
+            <a:off x="3325336" y="1762125"/>
+            <a:ext cx="5541328" cy="4572000"/>
           </a:xfrm>
           <a:prstGeom prst="rect">
             <a:avLst/>
@@ -13473,8 +13473,8 @@
         </p:blipFill>
         <p:spPr>
           <a:xfrm>
-            <a:off x="3810000" y="1762125"/>
-            <a:ext cx="4572000" cy="4572000"/>
+            <a:off x="3541935" y="1762125"/>
+            <a:ext cx="5108130" cy="4572000"/>
           </a:xfrm>
           <a:prstGeom prst="rect">
             <a:avLst/>
@@ -13689,8 +13689,8 @@
         </p:blipFill>
         <p:spPr>
           <a:xfrm>
-            <a:off x="3810000" y="1762125"/>
-            <a:ext cx="4572000" cy="4572000"/>
+            <a:off x="3800032" y="1762125"/>
+            <a:ext cx="4591936" cy="4572000"/>
           </a:xfrm>
           <a:prstGeom prst="rect">
             <a:avLst/>

</xml_diff>

<commit_message>
Add Lesson 10-2 Key Sentences PPT; fix 10-1 cover aspect ratio
Key Sentences deck follows the Lesson 9-2 template: six expression/grammar
slides from the Lesson 10 worksheet, then click-to-reveal fill-in-the-blank
slides for basic, bonus and advanced sentences, and Look & Say.

Co-Authored-By: Claude Opus 5.5 <noreply@anthropic.com>
Claude-Session: https://claude.ai/code/session_01QJZ7rRRbNkEGT2jhq9EkC8
</commit_message>
<xml_diff>
--- a/ppt/Lesson10-1_New_Words.pptx
+++ b/ppt/Lesson10-1_New_Words.pptx
@@ -9909,8 +9909,8 @@
         </p:blipFill>
         <p:spPr>
           <a:xfrm>
-            <a:off x="4378253" y="3000375"/>
-            <a:ext cx="3435494" cy="3286125"/>
+            <a:off x="3896000" y="3013808"/>
+            <a:ext cx="4400000" cy="3259259"/>
           </a:xfrm>
           <a:prstGeom prst="rect">
             <a:avLst/>

</xml_diff>